<commit_message>
fix(content): apply fact-check corrections
- A1: update citation to ACM SIGCOMM CCR Vol.41 No.1 2011
- A5: fix author name format X. Yaxiong -> Y. Xie
- B5: update chip label BCM43455 -> CYW43455 (原BCM43455)
- B7: add note that nwifi.sys belongs to Native 802.11 arch (superseded by WDI in Win10)

Co-Authored-By: Claude Sonnet 4.6 <noreply@anthropic.com>
</commit_message>
<xml_diff>
--- a/output/network-card-csi-v5.0.pptx
+++ b/output/network-card-csi-v5.0.pptx
@@ -6492,7 +6492,7 @@
                   <a:srgbClr val="4A5FC1"/>
                 </a:solidFill>
               </a:rPr>
-              <a:t>▶ 職責：802.11 連線管理</a:t>
+              <a:t>▶ 職責：802.11 連線管理（Native 802.11 架構，Windows 10 起由 WDI 取代但概念相同）</a:t>
             </a:r>
           </a:p>
           <a:p>
@@ -13226,7 +13226,7 @@
                           </a:solidFill>
                           <a:latin typeface="Calibri"/>
                         </a:rPr>
-                        <a:t>BCM43455</a:t>
+                        <a:t>CYW43455 (原BCM43455)</a:t>
                       </a:r>
                     </a:p>
                   </a:txBody>
@@ -15891,7 +15891,7 @@
                 </a:solidFill>
                 <a:latin typeface="Calibri"/>
               </a:rPr>
-              <a:t>[1] D. Halperin et al., Tool Release: Gathering 802.11n Traces with CSI, ACM SIGCOMM, 2011. -&gt; linux-80211n-csitool</a:t>
+              <a:t>[1] D. Halperin et al., Tool Release: Gathering 802.11n Traces with CSI, ACM SIGCOMM CCR, Vol. 41, No. 1, 2011. -&gt; linux-80211n-csitool</a:t>
             </a:r>
           </a:p>
           <a:p>
@@ -15955,7 +15955,7 @@
                 </a:solidFill>
                 <a:latin typeface="Calibri"/>
               </a:rPr>
-              <a:t>[5] X. Yaxiong et al., Atheros CSI Tool for 802.11n NICs -- xieyaxiongfly/Atheros-CSI-Tool</a:t>
+              <a:t>[5] Y. Xie et al., Atheros CSI Tool for 802.11n NICs -- xieyaxiongfly/Atheros-CSI-Tool</a:t>
             </a:r>
           </a:p>
           <a:p>

</xml_diff>